<commit_message>
Rebuild slide 1 in the reference 9:16 portrait format
Co-authored-by: ilhanyusup-prog <ilhanyusup-prog@users.noreply.github.com>
</commit_message>
<xml_diff>
--- a/presentation.pptx
+++ b/presentation.pptx
@@ -7,7 +7,7 @@
   <p:sldIdLst>
     <p:sldId id="256" r:id="rId7"/>
   </p:sldIdLst>
-  <p:sldSz cx="12192000" cy="6858000" type="screen4x3"/>
+  <p:sldSz cx="6858000" cy="12191695" type="screen4x3"/>
   <p:notesSz cx="6858000" cy="9144000"/>
   <p:defaultTextStyle>
     <a:defPPr>
@@ -3097,7 +3097,7 @@
         <p:spPr>
           <a:xfrm>
             <a:off x="0" y="0"/>
-            <a:ext cx="12192000" cy="6858000"/>
+            <a:ext cx="6858000" cy="12192000"/>
           </a:xfrm>
           <a:prstGeom prst="rect">
             <a:avLst/>
@@ -3142,24 +3142,71 @@
         </p:nvPicPr>
         <p:blipFill>
           <a:blip r:embed="rId2"/>
-          <a:srcRect t="12260" b="26970"/>
           <a:stretch>
             <a:fillRect/>
           </a:stretch>
         </p:blipFill>
         <p:spPr>
           <a:xfrm>
-            <a:off x="5842000" y="0"/>
-            <a:ext cx="6350000" cy="6858000"/>
+            <a:off x="-1777" y="0"/>
+            <a:ext cx="6864350" cy="12192000"/>
           </a:xfrm>
           <a:prstGeom prst="rect">
             <a:avLst/>
           </a:prstGeom>
         </p:spPr>
       </p:pic>
+      <p:sp>
+        <p:nvSpPr>
+          <p:cNvPr id="4" name="Logo panel"/>
+          <p:cNvSpPr/>
+          <p:nvPr/>
+        </p:nvSpPr>
+        <p:spPr>
+          <a:xfrm>
+            <a:off x="2876550" y="635000"/>
+            <a:ext cx="1104900" cy="889000"/>
+          </a:xfrm>
+          <a:prstGeom prst="roundRect">
+            <a:avLst>
+              <a:gd name="adj" fmla="val 11428"/>
+            </a:avLst>
+          </a:prstGeom>
+          <a:solidFill>
+            <a:srgbClr val="7F7F7F">
+              <a:alpha val="7800"/>
+            </a:srgbClr>
+          </a:solidFill>
+          <a:ln>
+            <a:noFill/>
+          </a:ln>
+          <a:effectLst/>
+        </p:spPr>
+        <p:style>
+          <a:lnRef idx="1">
+            <a:schemeClr val="accent1"/>
+          </a:lnRef>
+          <a:fillRef idx="3">
+            <a:schemeClr val="accent1"/>
+          </a:fillRef>
+          <a:effectRef idx="2">
+            <a:schemeClr val="accent1"/>
+          </a:effectRef>
+          <a:fontRef idx="minor">
+            <a:schemeClr val="lt1"/>
+          </a:fontRef>
+        </p:style>
+        <p:txBody>
+          <a:bodyPr rtlCol="0" anchor="ctr"/>
+          <a:lstStyle/>
+          <a:p>
+            <a:pPr algn="ctr"/>
+          </a:p>
+        </p:txBody>
+      </p:sp>
       <p:pic>
         <p:nvPicPr>
-          <p:cNvPr id="4" name="Almuhib Solar Energy logo" descr="logo_apm.png"/>
+          <p:cNvPr id="5" name="Almuhib Solar Energy logo" descr="logo_apm.png"/>
           <p:cNvPicPr>
             <a:picLocks noChangeAspect="1"/>
           </p:cNvPicPr>
@@ -3173,8 +3220,8 @@
         </p:blipFill>
         <p:spPr>
           <a:xfrm>
-            <a:off x="711200" y="431800"/>
-            <a:ext cx="1270000" cy="1021080"/>
+            <a:off x="2876550" y="636185"/>
+            <a:ext cx="1104900" cy="889000"/>
           </a:xfrm>
           <a:prstGeom prst="rect">
             <a:avLst/>
@@ -3183,14 +3230,14 @@
       </p:pic>
       <p:sp>
         <p:nvSpPr>
-          <p:cNvPr id="5" name="Accent dash"/>
+          <p:cNvPr id="6" name="Accent dash"/>
           <p:cNvSpPr/>
           <p:nvPr/>
         </p:nvSpPr>
         <p:spPr>
           <a:xfrm>
-            <a:off x="711200" y="2978150"/>
-            <a:ext cx="373380" cy="53340"/>
+            <a:off x="406400" y="8636000"/>
+            <a:ext cx="355600" cy="50800"/>
           </a:xfrm>
           <a:prstGeom prst="roundRect">
             <a:avLst>
@@ -3237,14 +3284,14 @@
       </p:sp>
       <p:sp>
         <p:nvSpPr>
-          <p:cNvPr id="6" name="Eyebrow - reference"/>
+          <p:cNvPr id="7" name="Eyebrow - reference"/>
           <p:cNvSpPr txBox="1"/>
           <p:nvPr/>
         </p:nvSpPr>
         <p:spPr>
           <a:xfrm>
-            <a:off x="1244600" y="2833846"/>
-            <a:ext cx="5080000" cy="331787"/>
+            <a:off x="914400" y="8494818"/>
+            <a:ext cx="4402666" cy="323850"/>
           </a:xfrm>
           <a:prstGeom prst="rect">
             <a:avLst/>
@@ -3259,7 +3306,7 @@
           <a:p>
             <a:pPr algn="l"/>
             <a:r>
-              <a:rPr sz="1450" b="1" spc="261">
+              <a:rPr sz="1400" b="1" spc="252">
                 <a:solidFill>
                   <a:srgbClr val="A3ABAA"/>
                 </a:solidFill>
@@ -3272,14 +3319,14 @@
       </p:sp>
       <p:sp>
         <p:nvSpPr>
-          <p:cNvPr id="7" name="Headline"/>
+          <p:cNvPr id="8" name="Headline"/>
           <p:cNvSpPr txBox="1"/>
           <p:nvPr/>
         </p:nvSpPr>
         <p:spPr>
           <a:xfrm>
-            <a:off x="711200" y="3380740"/>
-            <a:ext cx="5842000" cy="1463040"/>
+            <a:off x="406400" y="9013613"/>
+            <a:ext cx="5418666" cy="1397000"/>
           </a:xfrm>
           <a:prstGeom prst="rect">
             <a:avLst/>
@@ -3294,11 +3341,11 @@
           <a:p>
             <a:pPr algn="l">
               <a:lnSpc>
-                <a:spcPts val="5360"/>
+                <a:spcPts val="5100"/>
               </a:lnSpc>
             </a:pPr>
             <a:r>
-              <a:rPr sz="5250" b="0" spc="-158">
+              <a:rPr sz="5000" b="0" spc="-150">
                 <a:solidFill>
                   <a:srgbClr val="FFFFFF"/>
                 </a:solidFill>
@@ -3310,11 +3357,11 @@
           <a:p>
             <a:pPr algn="l">
               <a:lnSpc>
-                <a:spcPts val="5360"/>
+                <a:spcPts val="5100"/>
               </a:lnSpc>
             </a:pPr>
             <a:r>
-              <a:rPr sz="5250" b="0" spc="-158">
+              <a:rPr sz="5000" b="0" spc="-150">
                 <a:solidFill>
                   <a:srgbClr val="FFFFFF"/>
                 </a:solidFill>
@@ -3327,14 +3374,14 @@
       </p:sp>
       <p:sp>
         <p:nvSpPr>
-          <p:cNvPr id="8" name="Label - prepared for"/>
+          <p:cNvPr id="9" name="Label - prepared for"/>
           <p:cNvSpPr txBox="1"/>
           <p:nvPr/>
         </p:nvSpPr>
         <p:spPr>
           <a:xfrm>
-            <a:off x="711200" y="5155406"/>
-            <a:ext cx="2794000" cy="331787"/>
+            <a:off x="406400" y="10704618"/>
+            <a:ext cx="2709333" cy="323850"/>
           </a:xfrm>
           <a:prstGeom prst="rect">
             <a:avLst/>
@@ -3349,7 +3396,7 @@
           <a:p>
             <a:pPr algn="l"/>
             <a:r>
-              <a:rPr sz="1450" b="1" spc="261">
+              <a:rPr sz="1400" b="1" spc="252">
                 <a:solidFill>
                   <a:srgbClr val="859290"/>
                 </a:solidFill>
@@ -3362,14 +3409,14 @@
       </p:sp>
       <p:sp>
         <p:nvSpPr>
-          <p:cNvPr id="9" name="Client name"/>
+          <p:cNvPr id="10" name="Client name"/>
           <p:cNvSpPr txBox="1"/>
           <p:nvPr/>
         </p:nvSpPr>
         <p:spPr>
           <a:xfrm>
-            <a:off x="711200" y="5428932"/>
-            <a:ext cx="2794000" cy="434975"/>
+            <a:off x="406400" y="10967296"/>
+            <a:ext cx="2709333" cy="419100"/>
           </a:xfrm>
           <a:prstGeom prst="rect">
             <a:avLst/>
@@ -3384,7 +3431,7 @@
           <a:p>
             <a:pPr algn="l"/>
             <a:r>
-              <a:rPr sz="2100" b="1">
+              <a:rPr sz="2000" b="1">
                 <a:solidFill>
                   <a:srgbClr val="FFFFFF"/>
                 </a:solidFill>
@@ -3397,14 +3444,14 @@
       </p:sp>
       <p:sp>
         <p:nvSpPr>
-          <p:cNvPr id="10" name="Client community"/>
+          <p:cNvPr id="11" name="Client community"/>
           <p:cNvSpPr txBox="1"/>
           <p:nvPr/>
         </p:nvSpPr>
         <p:spPr>
           <a:xfrm>
-            <a:off x="711200" y="5801360"/>
-            <a:ext cx="2794000" cy="368300"/>
+            <a:off x="406400" y="11321626"/>
+            <a:ext cx="2709333" cy="355600"/>
           </a:xfrm>
           <a:prstGeom prst="rect">
             <a:avLst/>
@@ -3419,7 +3466,7 @@
           <a:p>
             <a:pPr algn="l"/>
             <a:r>
-              <a:rPr sz="1680" b="0">
+              <a:rPr sz="1600" b="0">
                 <a:solidFill>
                   <a:srgbClr val="AAB3B1"/>
                 </a:solidFill>
@@ -3432,14 +3479,14 @@
       </p:sp>
       <p:sp>
         <p:nvSpPr>
-          <p:cNvPr id="11" name="Proposal date"/>
+          <p:cNvPr id="12" name="Proposal date"/>
           <p:cNvSpPr txBox="1"/>
           <p:nvPr/>
         </p:nvSpPr>
         <p:spPr>
           <a:xfrm>
-            <a:off x="711200" y="6206490"/>
-            <a:ext cx="2794000" cy="368300"/>
+            <a:off x="406400" y="11708553"/>
+            <a:ext cx="2709333" cy="355600"/>
           </a:xfrm>
           <a:prstGeom prst="rect">
             <a:avLst/>
@@ -3454,7 +3501,7 @@
           <a:p>
             <a:pPr algn="l"/>
             <a:r>
-              <a:rPr sz="1680" b="0">
+              <a:rPr sz="1600" b="0">
                 <a:solidFill>
                   <a:srgbClr val="859290"/>
                 </a:solidFill>
@@ -3467,14 +3514,14 @@
       </p:sp>
       <p:sp>
         <p:nvSpPr>
-          <p:cNvPr id="12" name="Meta divider"/>
+          <p:cNvPr id="13" name="Meta divider"/>
           <p:cNvSpPr/>
           <p:nvPr/>
         </p:nvSpPr>
         <p:spPr>
           <a:xfrm>
-            <a:off x="3637279" y="5218430"/>
-            <a:ext cx="15240" cy="1374140"/>
+            <a:off x="3194050" y="10769600"/>
+            <a:ext cx="12700" cy="1308100"/>
           </a:xfrm>
           <a:prstGeom prst="rect">
             <a:avLst/>
@@ -3513,14 +3560,14 @@
       </p:sp>
       <p:sp>
         <p:nvSpPr>
-          <p:cNvPr id="13" name="Label - system size"/>
+          <p:cNvPr id="14" name="Label - system size"/>
           <p:cNvSpPr txBox="1"/>
           <p:nvPr/>
         </p:nvSpPr>
         <p:spPr>
           <a:xfrm>
-            <a:off x="3945890" y="5155406"/>
-            <a:ext cx="2794000" cy="331787"/>
+            <a:off x="3486573" y="10704618"/>
+            <a:ext cx="2455333" cy="323850"/>
           </a:xfrm>
           <a:prstGeom prst="rect">
             <a:avLst/>
@@ -3535,7 +3582,7 @@
           <a:p>
             <a:pPr algn="l"/>
             <a:r>
-              <a:rPr sz="1450" b="1" spc="261">
+              <a:rPr sz="1400" b="1" spc="252">
                 <a:solidFill>
                   <a:srgbClr val="859290"/>
                 </a:solidFill>
@@ -3548,14 +3595,14 @@
       </p:sp>
       <p:sp>
         <p:nvSpPr>
-          <p:cNvPr id="14" name="System size"/>
+          <p:cNvPr id="15" name="System size"/>
           <p:cNvSpPr txBox="1"/>
           <p:nvPr/>
         </p:nvSpPr>
         <p:spPr>
           <a:xfrm>
-            <a:off x="3945890" y="5413375"/>
-            <a:ext cx="2623820" cy="1195070"/>
+            <a:off x="3486573" y="10952479"/>
+            <a:ext cx="2455333" cy="1143000"/>
           </a:xfrm>
           <a:prstGeom prst="rect">
             <a:avLst/>
@@ -3570,11 +3617,11 @@
           <a:p>
             <a:pPr algn="l">
               <a:lnSpc>
-                <a:spcPts val="2870"/>
+                <a:spcPts val="2733"/>
               </a:lnSpc>
             </a:pPr>
             <a:r>
-              <a:rPr sz="2100" b="0">
+              <a:rPr sz="2000" b="0">
                 <a:solidFill>
                   <a:srgbClr val="FFFFFF"/>
                 </a:solidFill>
@@ -3586,11 +3633,11 @@
           <a:p>
             <a:pPr algn="l">
               <a:lnSpc>
-                <a:spcPts val="2870"/>
+                <a:spcPts val="2733"/>
               </a:lnSpc>
             </a:pPr>
             <a:r>
-              <a:rPr sz="2100" b="0">
+              <a:rPr sz="2000" b="0">
                 <a:solidFill>
                   <a:srgbClr val="FFFFFF"/>
                 </a:solidFill>
@@ -3599,7 +3646,7 @@
               <a:t>covers </a:t>
             </a:r>
             <a:r>
-              <a:rPr sz="2100" b="0">
+              <a:rPr sz="2000" b="0">
                 <a:solidFill>
                   <a:srgbClr val="6FE39C"/>
                 </a:solidFill>
@@ -3608,7 +3655,7 @@
               <a:t>84%</a:t>
             </a:r>
             <a:r>
-              <a:rPr sz="2100" b="0">
+              <a:rPr sz="2000" b="0">
                 <a:solidFill>
                   <a:srgbClr val="FFFFFF"/>
                 </a:solidFill>
@@ -3620,11 +3667,11 @@
           <a:p>
             <a:pPr algn="l">
               <a:lnSpc>
-                <a:spcPts val="2870"/>
+                <a:spcPts val="2733"/>
               </a:lnSpc>
             </a:pPr>
             <a:r>
-              <a:rPr sz="2100" b="0">
+              <a:rPr sz="2000" b="0">
                 <a:solidFill>
                   <a:srgbClr val="FFFFFF"/>
                 </a:solidFill>
@@ -3637,14 +3684,14 @@
       </p:sp>
       <p:sp>
         <p:nvSpPr>
-          <p:cNvPr id="15" name="Progress rail track"/>
+          <p:cNvPr id="16" name="Progress rail track"/>
           <p:cNvSpPr/>
           <p:nvPr/>
         </p:nvSpPr>
         <p:spPr>
           <a:xfrm>
-            <a:off x="11684000" y="355600"/>
-            <a:ext cx="50800" cy="6146800"/>
+            <a:off x="6540500" y="635000"/>
+            <a:ext cx="38100" cy="10922000"/>
           </a:xfrm>
           <a:prstGeom prst="roundRect">
             <a:avLst>
@@ -3685,14 +3732,14 @@
       </p:sp>
       <p:sp>
         <p:nvSpPr>
-          <p:cNvPr id="16" name="Progress rail fill"/>
+          <p:cNvPr id="17" name="Progress rail fill"/>
           <p:cNvSpPr/>
           <p:nvPr/>
         </p:nvSpPr>
         <p:spPr>
           <a:xfrm>
-            <a:off x="11684000" y="355600"/>
-            <a:ext cx="50800" cy="472830"/>
+            <a:off x="6540500" y="635000"/>
+            <a:ext cx="38100" cy="840153"/>
           </a:xfrm>
           <a:prstGeom prst="roundRect">
             <a:avLst>
@@ -3739,14 +3786,14 @@
       </p:sp>
       <p:sp>
         <p:nvSpPr>
-          <p:cNvPr id="17" name="Progress dot glow 24"/>
+          <p:cNvPr id="18" name="Progress dot glow 2.1x"/>
           <p:cNvSpPr/>
           <p:nvPr/>
         </p:nvSpPr>
         <p:spPr>
           <a:xfrm>
-            <a:off x="11557000" y="676030"/>
-            <a:ext cx="304800" cy="304800"/>
+            <a:off x="6456426" y="1372029"/>
+            <a:ext cx="206247" cy="206247"/>
           </a:xfrm>
           <a:prstGeom prst="ellipse">
             <a:avLst/>
@@ -3785,14 +3832,14 @@
       </p:sp>
       <p:sp>
         <p:nvSpPr>
-          <p:cNvPr id="18" name="Progress dot glow 18"/>
+          <p:cNvPr id="19" name="Progress dot glow 1.55x"/>
           <p:cNvSpPr/>
           <p:nvPr/>
         </p:nvSpPr>
         <p:spPr>
           <a:xfrm>
-            <a:off x="11595100" y="714130"/>
-            <a:ext cx="228600" cy="228600"/>
+            <a:off x="6483434" y="1399038"/>
+            <a:ext cx="152230" cy="152230"/>
           </a:xfrm>
           <a:prstGeom prst="ellipse">
             <a:avLst/>
@@ -3831,14 +3878,14 @@
       </p:sp>
       <p:sp>
         <p:nvSpPr>
-          <p:cNvPr id="19" name="Progress dot"/>
+          <p:cNvPr id="20" name="Progress dot"/>
           <p:cNvSpPr/>
           <p:nvPr/>
         </p:nvSpPr>
         <p:spPr>
           <a:xfrm>
-            <a:off x="11645900" y="764930"/>
-            <a:ext cx="127000" cy="127000"/>
+            <a:off x="6510443" y="1426047"/>
+            <a:ext cx="98213" cy="98213"/>
           </a:xfrm>
           <a:prstGeom prst="ellipse">
             <a:avLst/>
@@ -3875,14 +3922,14 @@
       </p:sp>
       <p:sp>
         <p:nvSpPr>
-          <p:cNvPr id="20" name="Slide number"/>
+          <p:cNvPr id="21" name="Slide number"/>
           <p:cNvSpPr txBox="1"/>
           <p:nvPr/>
         </p:nvSpPr>
         <p:spPr>
           <a:xfrm>
-            <a:off x="10915650" y="662537"/>
-            <a:ext cx="635000" cy="331787"/>
+            <a:off x="5566833" y="1293918"/>
+            <a:ext cx="846666" cy="323850"/>
           </a:xfrm>
           <a:prstGeom prst="rect">
             <a:avLst/>
@@ -3897,7 +3944,7 @@
           <a:p>
             <a:pPr algn="r"/>
             <a:r>
-              <a:rPr sz="1450" b="1">
+              <a:rPr sz="1400" b="1">
                 <a:solidFill>
                   <a:srgbClr val="BCC2C1"/>
                 </a:solidFill>

</xml_diff>

<commit_message>
Split the deck into per-slide modules with a shared kit and reference tools
Co-authored-by: ilhanyusup-prog <ilhanyusup-prog@users.noreply.github.com>
</commit_message>
<xml_diff>
--- a/presentation.pptx
+++ b/presentation.pptx
@@ -3103,7 +3103,7 @@
             <a:avLst/>
           </a:prstGeom>
           <a:solidFill>
-            <a:srgbClr val="08241E"/>
+            <a:srgbClr val="06251C"/>
           </a:solidFill>
           <a:ln>
             <a:noFill/>
@@ -3169,7 +3169,7 @@
           </a:xfrm>
           <a:prstGeom prst="roundRect">
             <a:avLst>
-              <a:gd name="adj" fmla="val 11428"/>
+              <a:gd name="adj" fmla="val 11400"/>
             </a:avLst>
           </a:prstGeom>
           <a:solidFill>
@@ -3206,7 +3206,7 @@
       </p:sp>
       <p:pic>
         <p:nvPicPr>
-          <p:cNvPr id="5" name="Almuhib Solar Energy logo" descr="logo_apm.png"/>
+          <p:cNvPr id="5" name="Almuhib Solar Energy logo" descr="logo_mark.png"/>
           <p:cNvPicPr>
             <a:picLocks noChangeAspect="1"/>
           </p:cNvPicPr>
@@ -3220,7 +3220,7 @@
         </p:blipFill>
         <p:spPr>
           <a:xfrm>
-            <a:off x="2876550" y="636185"/>
+            <a:off x="2876550" y="635000"/>
             <a:ext cx="1104900" cy="889000"/>
           </a:xfrm>
           <a:prstGeom prst="rect">
@@ -3623,7 +3623,7 @@
             <a:r>
               <a:rPr sz="2000" b="0">
                 <a:solidFill>
-                  <a:srgbClr val="FFFFFF"/>
+                  <a:srgbClr val="06251C"/>
                 </a:solidFill>
                 <a:latin typeface="Arial"/>
               </a:rPr>
@@ -3639,7 +3639,7 @@
             <a:r>
               <a:rPr sz="2000" b="0">
                 <a:solidFill>
-                  <a:srgbClr val="FFFFFF"/>
+                  <a:srgbClr val="06251C"/>
                 </a:solidFill>
                 <a:latin typeface="Arial"/>
               </a:rPr>
@@ -3657,7 +3657,7 @@
             <a:r>
               <a:rPr sz="2000" b="0">
                 <a:solidFill>
-                  <a:srgbClr val="FFFFFF"/>
+                  <a:srgbClr val="06251C"/>
                 </a:solidFill>
                 <a:latin typeface="Arial"/>
               </a:rPr>
@@ -3673,7 +3673,7 @@
             <a:r>
               <a:rPr sz="2000" b="0">
                 <a:solidFill>
-                  <a:srgbClr val="FFFFFF"/>
+                  <a:srgbClr val="06251C"/>
                 </a:solidFill>
                 <a:latin typeface="Arial"/>
               </a:rPr>
@@ -3922,7 +3922,7 @@
       </p:sp>
       <p:sp>
         <p:nvSpPr>
-          <p:cNvPr id="21" name="Slide number"/>
+          <p:cNvPr id="21" name="Page number"/>
           <p:cNvSpPr txBox="1"/>
           <p:nvPr/>
         </p:nvSpPr>

</xml_diff>